<commit_message>
Refine SF6 motivation and update review artifacts
</commit_message>
<xml_diff>
--- a/src/site/documents/Sakala_Rozprava_2026_CVUT_reviewed.pptx
+++ b/src/site/documents/Sakala_Rozprava_2026_CVUT_reviewed.pptx
@@ -2,44 +2,44 @@
 <file path=ppt/presentation.xml><?xml version="1.0" encoding="utf-8"?>
 <p:presentation xmlns:p="http://schemas.openxmlformats.org/presentationml/2006/main" embedTrueTypeFonts="1" saveSubsetFonts="0">
   <p:sldMasterIdLst>
-    <p:sldMasterId xmlns:r="http://schemas.openxmlformats.org/officeDocument/2006/relationships" id="2147483648" r:id="R38650ec7e2e7494f"/>
+    <p:sldMasterId xmlns:r="http://schemas.openxmlformats.org/officeDocument/2006/relationships" id="2147483648" r:id="R36c3e2f2a9704224"/>
   </p:sldMasterIdLst>
   <p:notesMasterIdLst>
-    <p:notesMasterId xmlns:r="http://schemas.openxmlformats.org/officeDocument/2006/relationships" r:id="Raeb39f0389224796"/>
+    <p:notesMasterId xmlns:r="http://schemas.openxmlformats.org/officeDocument/2006/relationships" r:id="R63ff8c4e807e4281"/>
   </p:notesMasterIdLst>
   <p:sldIdLst>
-    <p:sldId xmlns:r="http://schemas.openxmlformats.org/officeDocument/2006/relationships" id="256" r:id="Rdbaab46b081a4424"/>
-    <p:sldId xmlns:r="http://schemas.openxmlformats.org/officeDocument/2006/relationships" id="257" r:id="R5e235be372c34680"/>
-    <p:sldId xmlns:r="http://schemas.openxmlformats.org/officeDocument/2006/relationships" id="258" r:id="R91795c08b9114930"/>
-    <p:sldId xmlns:r="http://schemas.openxmlformats.org/officeDocument/2006/relationships" id="259" r:id="Rb8296f9546604b89"/>
-    <p:sldId xmlns:r="http://schemas.openxmlformats.org/officeDocument/2006/relationships" id="260" r:id="Rffc6990022ca4f44"/>
-    <p:sldId xmlns:r="http://schemas.openxmlformats.org/officeDocument/2006/relationships" id="261" r:id="R62cd3c20c5d64060"/>
-    <p:sldId xmlns:r="http://schemas.openxmlformats.org/officeDocument/2006/relationships" id="262" r:id="R1baa40aba83744e8"/>
-    <p:sldId xmlns:r="http://schemas.openxmlformats.org/officeDocument/2006/relationships" id="263" r:id="R3cccae2737014797"/>
-    <p:sldId xmlns:r="http://schemas.openxmlformats.org/officeDocument/2006/relationships" id="264" r:id="R6910ce6528f34738"/>
-    <p:sldId xmlns:r="http://schemas.openxmlformats.org/officeDocument/2006/relationships" id="265" r:id="Re510f6aa0e86485f"/>
-    <p:sldId xmlns:r="http://schemas.openxmlformats.org/officeDocument/2006/relationships" id="266" r:id="Rf3416c8c01ba4fda"/>
-    <p:sldId xmlns:r="http://schemas.openxmlformats.org/officeDocument/2006/relationships" id="267" r:id="R494d6ee8592a4413"/>
-    <p:sldId xmlns:r="http://schemas.openxmlformats.org/officeDocument/2006/relationships" id="268" r:id="Rd639fb3bd14a4b0d"/>
-    <p:sldId xmlns:r="http://schemas.openxmlformats.org/officeDocument/2006/relationships" id="269" r:id="Ra42f0cf0a09e440d"/>
-    <p:sldId xmlns:r="http://schemas.openxmlformats.org/officeDocument/2006/relationships" id="270" r:id="R9d578bdd46834556"/>
-    <p:sldId xmlns:r="http://schemas.openxmlformats.org/officeDocument/2006/relationships" id="271" r:id="R61233568d4394a8b"/>
-    <p:sldId xmlns:r="http://schemas.openxmlformats.org/officeDocument/2006/relationships" id="272" r:id="R5f8910ae0bd34a85"/>
-    <p:sldId xmlns:r="http://schemas.openxmlformats.org/officeDocument/2006/relationships" id="273" r:id="Ree5ab724cbe24526"/>
+    <p:sldId xmlns:r="http://schemas.openxmlformats.org/officeDocument/2006/relationships" id="256" r:id="R371a368cb75b4cc3"/>
+    <p:sldId xmlns:r="http://schemas.openxmlformats.org/officeDocument/2006/relationships" id="257" r:id="R692384d9b6fe4af6"/>
+    <p:sldId xmlns:r="http://schemas.openxmlformats.org/officeDocument/2006/relationships" id="258" r:id="R6e24c4a4d65c450f"/>
+    <p:sldId xmlns:r="http://schemas.openxmlformats.org/officeDocument/2006/relationships" id="259" r:id="Ra7559721c88b4532"/>
+    <p:sldId xmlns:r="http://schemas.openxmlformats.org/officeDocument/2006/relationships" id="260" r:id="R18f1226a315b4898"/>
+    <p:sldId xmlns:r="http://schemas.openxmlformats.org/officeDocument/2006/relationships" id="261" r:id="R8cba09e163aa4d55"/>
+    <p:sldId xmlns:r="http://schemas.openxmlformats.org/officeDocument/2006/relationships" id="262" r:id="R3550f2753a2748ec"/>
+    <p:sldId xmlns:r="http://schemas.openxmlformats.org/officeDocument/2006/relationships" id="263" r:id="Rf498bad7d8454ad8"/>
+    <p:sldId xmlns:r="http://schemas.openxmlformats.org/officeDocument/2006/relationships" id="264" r:id="R7a76cc25dcf748dc"/>
+    <p:sldId xmlns:r="http://schemas.openxmlformats.org/officeDocument/2006/relationships" id="265" r:id="R406cbba3b2ca4800"/>
+    <p:sldId xmlns:r="http://schemas.openxmlformats.org/officeDocument/2006/relationships" id="266" r:id="R3656e9f7e8ac45f3"/>
+    <p:sldId xmlns:r="http://schemas.openxmlformats.org/officeDocument/2006/relationships" id="267" r:id="R35c3503fba2843d4"/>
+    <p:sldId xmlns:r="http://schemas.openxmlformats.org/officeDocument/2006/relationships" id="268" r:id="Ref1931ddf8574a4c"/>
+    <p:sldId xmlns:r="http://schemas.openxmlformats.org/officeDocument/2006/relationships" id="269" r:id="R1766a20a834349bc"/>
+    <p:sldId xmlns:r="http://schemas.openxmlformats.org/officeDocument/2006/relationships" id="270" r:id="R674fdcc8a0f24612"/>
+    <p:sldId xmlns:r="http://schemas.openxmlformats.org/officeDocument/2006/relationships" id="271" r:id="R8734638affee4cd4"/>
+    <p:sldId xmlns:r="http://schemas.openxmlformats.org/officeDocument/2006/relationships" id="272" r:id="R4e8071e19061460b"/>
+    <p:sldId xmlns:r="http://schemas.openxmlformats.org/officeDocument/2006/relationships" id="273" r:id="Rfabe7c600e6e4c36"/>
   </p:sldIdLst>
   <p:sldSz cx="9144000" cy="6858000"/>
   <p:notesSz cx="6858000" cy="9144000"/>
   <p:embeddedFontLst>
     <p:embeddedFont>
       <p:font typeface="Technika"/>
-      <p:regular xmlns:r="http://schemas.openxmlformats.org/officeDocument/2006/relationships" r:id="Rdba841fd5f5b48a8"/>
-      <p:bold xmlns:r="http://schemas.openxmlformats.org/officeDocument/2006/relationships" r:id="R819ed40ea3ae4edb"/>
-      <p:italic xmlns:r="http://schemas.openxmlformats.org/officeDocument/2006/relationships" r:id="R7c42cf049f7b4f3f"/>
-      <p:boldItalic xmlns:r="http://schemas.openxmlformats.org/officeDocument/2006/relationships" r:id="Re681bc1431cb4729"/>
+      <p:regular xmlns:r="http://schemas.openxmlformats.org/officeDocument/2006/relationships" r:id="Rd359455281f34358"/>
+      <p:bold xmlns:r="http://schemas.openxmlformats.org/officeDocument/2006/relationships" r:id="R0dca4b92f8c247c1"/>
+      <p:italic xmlns:r="http://schemas.openxmlformats.org/officeDocument/2006/relationships" r:id="Re71043c9fb174917"/>
+      <p:boldItalic xmlns:r="http://schemas.openxmlformats.org/officeDocument/2006/relationships" r:id="Ra9f6fa0c6c65438c"/>
     </p:embeddedFont>
     <p:embeddedFont>
       <p:font typeface="Technika-Bold"/>
-      <p:regular xmlns:r="http://schemas.openxmlformats.org/officeDocument/2006/relationships" r:id="Re2a2eba4fd7c4667"/>
+      <p:regular xmlns:r="http://schemas.openxmlformats.org/officeDocument/2006/relationships" r:id="R3e830c9c37ef4ac8"/>
     </p:embeddedFont>
   </p:embeddedFontLst>
 </p:presentation>
@@ -418,7 +418,7 @@
           <a:lstStyle xmlns:a="http://schemas.openxmlformats.org/drawingml/2006/main"/>
           <a:p xmlns:a="http://schemas.openxmlformats.org/drawingml/2006/main">
             <a:r>
-              <a:t>Návrh rozsahu pro odbornou rozpravu po prvních dvou letech. Povinný Tier 1 zahrnuje atmosférický vzduch, predikci a TCO. Odevzdání srpen 2028. Tier 2 a 3 jsou mimo povinné dokončení. Šablona: ČVUT, https://www.cvut.cz/logo-a-graficky-manual, soubor PowerPoint_CS.potx. Hlavní část přibližně 15–20 minut; přesný čas podle pozvánky.</a:t>
+              <a:t>Návrh rozsahu pro odbornou rozpravu po prvních dvou letech. Povinný Tier 1 zahrnuje atmosférický vzduch, predikci a TCO. Širší aplikační kontext je přechod od SF₆. Tier 1 zkoumá laserem vyvolané sepnutí atmosférické mezery. Netestuje náhradu izolace ani funkci výkonového vypínače. Odevzdání srpen 2028. Tier 2 a 3 jsou mimo povinné dokončení. Šablona: ČVUT, https://www.cvut.cz/logo-a-graficky-manual, soubor PowerPoint_CS.potx. Hlavní část přibližně 15 až 20 minut. Přesný čas podle pozvánky.</a:t>
             </a:r>
           </a:p>
           <a:p xmlns:a="http://schemas.openxmlformats.org/drawingml/2006/main">
@@ -1128,7 +1128,12 @@
           <a:lstStyle xmlns:a="http://schemas.openxmlformats.org/drawingml/2006/main"/>
           <a:p xmlns:a="http://schemas.openxmlformats.org/drawingml/2006/main">
             <a:r>
-              <a:t>Dlouhodobým cílem programu W je přispět k náhradě SF₆ technicky a ekonomicky životaschopnými vysokonapěťovými zařízeními. Tier 1 vytváří měřicí, predikční a ekonomický základ. Tier 2 může ověřit přenos do CO₂ a tlakových podmínek, Tier 3 navázat aplikacemi. Prokázání úplné náhrady SF₆ není podmínkou odevzdání disertace. W znamená celý výzkumný program. Disertace je vymezena Tier 1; CO₂ není podmínkou názvu ani výsledků disertace. Jde o uživatelem zvolený plán, nikoli o tvrzení, že jej již schválila komise.</a:t>
+              <a:t>Přechod od SF₆ je reálný regulační a průmyslový kontext. SF₆ však v rozváděčích zajišťuje elektrickou izolaci a zhášení oblouku. Současný Tier 1 studuje pouze laserem vyvolané sepnutí atmosférické mezery. Neprokazuje izolační koordinaci, přerušení zkratového proudu, post-arc dielektrické zotavení ani produktovou životnost. Přímou vazbu na náhradu SF₆ lze tvrdit až po validaci konkrétní spínací funkce, média, napěťového a proudového dimenzování a pracovního cyklu. Tier 2 může ověřit přenos metody do CO₂ a tlakového režimu. Tier 3 může řešit vybranou aplikaci. Ani jeden není podmínkou odevzdání v srpnu 2028.</a:t>
+            </a:r>
+          </a:p>
+          <a:p xmlns:a="http://schemas.openxmlformats.org/drawingml/2006/main">
+            <a:r>
+              <a:t>Sources: Regulation (EU) 2024/573, Article 13, https://eur-lex.europa.eu/eli/reg/2024/573/oj. CIGRE WG A3.41, Current interruption in SF₆-free switchgear, Technical Brochure 871, 2022, https://electra.cigre.org/322-june-2022/technical-brochures/871-current-interruption-in-sf6-free-switchgear.html.</a:t>
             </a:r>
           </a:p>
         </p:txBody>
@@ -1674,7 +1679,7 @@
           <p:nvPr/>
         </p:nvPicPr>
         <p:blipFill rotWithShape="1">
-          <a:blip xmlns:r="http://schemas.openxmlformats.org/officeDocument/2006/relationships" xmlns:a="http://schemas.openxmlformats.org/drawingml/2006/main" r:embed="R733499d344b14d39"/>
+          <a:blip xmlns:r="http://schemas.openxmlformats.org/officeDocument/2006/relationships" xmlns:a="http://schemas.openxmlformats.org/drawingml/2006/main" r:embed="R816c3bc791634ab1"/>
           <a:srcRect xmlns:a="http://schemas.openxmlformats.org/drawingml/2006/main" l="0" t="-1" r="0" b="-1"/>
           <a:stretch xmlns:a="http://schemas.openxmlformats.org/drawingml/2006/main"/>
         </p:blipFill>
@@ -1840,7 +1845,7 @@
           <p:nvPr/>
         </p:nvPicPr>
         <p:blipFill>
-          <a:blip xmlns:r="http://schemas.openxmlformats.org/officeDocument/2006/relationships" xmlns:a="http://schemas.openxmlformats.org/drawingml/2006/main" r:embed="R4afd8b7c142741b0"/>
+          <a:blip xmlns:r="http://schemas.openxmlformats.org/officeDocument/2006/relationships" xmlns:a="http://schemas.openxmlformats.org/drawingml/2006/main" r:embed="R136f982813054371"/>
           <a:stretch xmlns:a="http://schemas.openxmlformats.org/drawingml/2006/main">
             <a:fillRect l="0" t="0" r="0" b="0"/>
           </a:stretch>
@@ -1881,7 +1886,7 @@
           <p:nvPr/>
         </p:nvPicPr>
         <p:blipFill rotWithShape="1">
-          <a:blip xmlns:r="http://schemas.openxmlformats.org/officeDocument/2006/relationships" xmlns:a="http://schemas.openxmlformats.org/drawingml/2006/main" r:embed="R4d9219a7cecf4e55"/>
+          <a:blip xmlns:r="http://schemas.openxmlformats.org/officeDocument/2006/relationships" xmlns:a="http://schemas.openxmlformats.org/drawingml/2006/main" r:embed="R9f99823fc5394627"/>
           <a:srcRect xmlns:a="http://schemas.openxmlformats.org/drawingml/2006/main" l="0" t="0" r="0" b="0"/>
           <a:stretch xmlns:a="http://schemas.openxmlformats.org/drawingml/2006/main"/>
         </p:blipFill>
@@ -1904,7 +1909,7 @@
           <p:nvPr/>
         </p:nvPicPr>
         <p:blipFill>
-          <a:blip xmlns:r="http://schemas.openxmlformats.org/officeDocument/2006/relationships" xmlns:a="http://schemas.openxmlformats.org/drawingml/2006/main" r:embed="R6656fdf206f147bd"/>
+          <a:blip xmlns:r="http://schemas.openxmlformats.org/officeDocument/2006/relationships" xmlns:a="http://schemas.openxmlformats.org/drawingml/2006/main" r:embed="R18a1d0b3230e43f0"/>
           <a:srcRect xmlns:a="http://schemas.openxmlformats.org/drawingml/2006/main" l="0" t="0" r="0" b="0"/>
           <a:stretch xmlns:a="http://schemas.openxmlformats.org/drawingml/2006/main">
             <a:fillRect l="0" t="0" r="0" b="0"/>
@@ -2490,7 +2495,7 @@
           <p:nvPr/>
         </p:nvPicPr>
         <p:blipFill>
-          <a:blip xmlns:r="http://schemas.openxmlformats.org/officeDocument/2006/relationships" xmlns:a="http://schemas.openxmlformats.org/drawingml/2006/main" r:embed="R3ebba90d1e764519"/>
+          <a:blip xmlns:r="http://schemas.openxmlformats.org/officeDocument/2006/relationships" xmlns:a="http://schemas.openxmlformats.org/drawingml/2006/main" r:embed="Rfed35eb2338e4d42"/>
           <a:srcRect xmlns:a="http://schemas.openxmlformats.org/drawingml/2006/main" l="0" t="0" r="0" b="0"/>
           <a:stretch xmlns:a="http://schemas.openxmlformats.org/drawingml/2006/main">
             <a:fillRect l="0" t="0" r="0" b="0"/>
@@ -2510,11 +2515,11 @@
   </p:cSld>
   <p:clrMap bg1="lt1" tx1="dk1" bg2="lt2" tx2="dk2" accent1="accent1" accent2="accent2" accent3="accent3" accent4="accent4" accent5="accent5" accent6="accent6" hlink="hlink" folHlink="folHlink"/>
   <p:sldLayoutIdLst>
-    <p:sldLayoutId xmlns:r="http://schemas.openxmlformats.org/officeDocument/2006/relationships" id="2147483649" r:id="R7c9422a675be4ff1"/>
-    <p:sldLayoutId xmlns:r="http://schemas.openxmlformats.org/officeDocument/2006/relationships" id="2147483650" r:id="Ra0b62cbc17d44767"/>
-    <p:sldLayoutId xmlns:r="http://schemas.openxmlformats.org/officeDocument/2006/relationships" id="2147483651" r:id="R9bbf3acf1b8e4baa"/>
-    <p:sldLayoutId xmlns:r="http://schemas.openxmlformats.org/officeDocument/2006/relationships" id="2147483652" r:id="Ra95fc6c1f82246e4"/>
-    <p:sldLayoutId xmlns:r="http://schemas.openxmlformats.org/officeDocument/2006/relationships" id="2147483653" r:id="R882fad74db3b429d"/>
+    <p:sldLayoutId xmlns:r="http://schemas.openxmlformats.org/officeDocument/2006/relationships" id="2147483649" r:id="Rfe523ed7b7674ef3"/>
+    <p:sldLayoutId xmlns:r="http://schemas.openxmlformats.org/officeDocument/2006/relationships" id="2147483650" r:id="Rda450103731f4caa"/>
+    <p:sldLayoutId xmlns:r="http://schemas.openxmlformats.org/officeDocument/2006/relationships" id="2147483651" r:id="Ra5b529903a824e24"/>
+    <p:sldLayoutId xmlns:r="http://schemas.openxmlformats.org/officeDocument/2006/relationships" id="2147483652" r:id="R524557f218304ac6"/>
+    <p:sldLayoutId xmlns:r="http://schemas.openxmlformats.org/officeDocument/2006/relationships" id="2147483653" r:id="R3e6ee01eefeb466d"/>
   </p:sldLayoutIdLst>
   <p:txStyles>
     <p:titleStyle>
@@ -3249,7 +3254,7 @@
                 <a:ea typeface="Technika"/>
                 <a:cs typeface="Technika"/>
               </a:rPr>
-              <a:t>Atmosférický základ pro dlouhodobý cíl: technicky a ekonomicky</a:t>
+              <a:t>Výzkum řízeného sepnutí vzduchové mezery v kontextu technologií bez SF₆.</a:t>
             </a:r>
           </a:p>
           <a:p xmlns:a="http://schemas.openxmlformats.org/drawingml/2006/main">
@@ -3273,7 +3278,7 @@
                 <a:ea typeface="Technika"/>
                 <a:cs typeface="Technika"/>
               </a:rPr>
-              <a:t>životaschopná vysokonapěťová zařízení bez SF₆.</a:t>
+              <a:t>Tier 1 neprokazuje náhradu celého rozváděče.</a:t>
             </a:r>
           </a:p>
         </p:txBody>
@@ -7157,7 +7162,7 @@
                 <a:ea typeface="Technika-Bold"/>
                 <a:cs typeface="Technika-Bold"/>
               </a:rPr>
-              <a:t>Dlouhodobý cíl a rozsah disertace</a:t>
+              <a:t>Aplikační kontext a rozsah disertace</a:t>
             </a:r>
             <a:endParaRPr/>
           </a:p>
@@ -7263,7 +7268,7 @@
                 <a:ea typeface="Technika"/>
                 <a:cs typeface="Technika"/>
               </a:rPr>
-              <a:t>Cíl programu: přispět k náhradě SF₆ ve vysokonapěťových zařízeních.</a:t>
+              <a:t>Kontext: přechod k technologiím bez SF₆ a F-plynů.</a:t>
             </a:r>
           </a:p>
         </p:txBody>
@@ -7321,7 +7326,7 @@
                 <a:ea typeface="Technika"/>
                 <a:cs typeface="Technika"/>
               </a:rPr>
-              <a:t>Tier 1: atmosférický vzduch, predikce a TCO.</a:t>
+              <a:t>Tier 1: řízené sepnutí vzduchové mezery, predikce a TCO.</a:t>
             </a:r>
           </a:p>
         </p:txBody>
@@ -7379,7 +7384,7 @@
                 <a:ea typeface="Technika"/>
                 <a:cs typeface="Technika"/>
               </a:rPr>
-              <a:t>Odevzdání disertace: srpen 2028.</a:t>
+              <a:t>Tier 1 netestuje izolaci, přerušení proudu ani dielektrické zotavení.</a:t>
             </a:r>
           </a:p>
         </p:txBody>
@@ -7437,7 +7442,7 @@
                 <a:ea typeface="Technika"/>
                 <a:cs typeface="Technika"/>
               </a:rPr>
-              <a:t>Tier 2 a 3: navazující výzkum mimo povinné dokončení.</a:t>
+              <a:t>Odevzdání 08/2028. Tier 2 a 3 jako samostatné pokračování.</a:t>
             </a:r>
           </a:p>
         </p:txBody>
@@ -8150,7 +8155,7 @@
           <p:nvPr/>
         </p:nvPicPr>
         <p:blipFill>
-          <a:blip xmlns:r="http://schemas.openxmlformats.org/officeDocument/2006/relationships" xmlns:a="http://schemas.openxmlformats.org/drawingml/2006/main" r:embed="Rf798fc67d91f4fb4"/>
+          <a:blip xmlns:r="http://schemas.openxmlformats.org/officeDocument/2006/relationships" xmlns:a="http://schemas.openxmlformats.org/drawingml/2006/main" r:embed="Rb17dde5652c74691"/>
           <a:stretch xmlns:a="http://schemas.openxmlformats.org/drawingml/2006/main"/>
         </p:blipFill>
         <p:spPr>
@@ -10836,13 +10841,13 @@
 </file>
 
 <file path=customXml/itemProps1.xml><?xml version="1.0" encoding="utf-8"?>
-<ds:datastoreItem xmlns:ds="http://schemas.openxmlformats.org/officeDocument/2006/customXml" ds:itemID="{E61DFFA2-A8B0-4D2F-86B6-456B50AD5D10}"/>
+<ds:datastoreItem xmlns:ds="http://schemas.openxmlformats.org/officeDocument/2006/customXml" ds:itemID="{5F217968-9E1A-44D1-8665-3311905331B5}"/>
 </file>
 
 <file path=customXml/itemProps2.xml><?xml version="1.0" encoding="utf-8"?>
-<ds:datastoreItem xmlns:ds="http://schemas.openxmlformats.org/officeDocument/2006/customXml" ds:itemID="{E9552D97-AF06-43CF-9CCC-789489FD50EB}"/>
+<ds:datastoreItem xmlns:ds="http://schemas.openxmlformats.org/officeDocument/2006/customXml" ds:itemID="{A84A42CC-8DB2-45C2-B271-524D7F98198C}"/>
 </file>
 
 <file path=customXml/itemProps3.xml><?xml version="1.0" encoding="utf-8"?>
-<ds:datastoreItem xmlns:ds="http://schemas.openxmlformats.org/officeDocument/2006/customXml" ds:itemID="{024889D1-DFE9-4C85-98AB-841F25DB04E9}"/>
+<ds:datastoreItem xmlns:ds="http://schemas.openxmlformats.org/officeDocument/2006/customXml" ds:itemID="{200AAFDB-2075-4D73-99CD-267B2BC156B0}"/>
 </file>
</xml_diff>

<commit_message>
docs: update application context, stochastic dynamics and research scope across notes
</commit_message>
<xml_diff>
--- a/src/site/documents/Sakala_Rozprava_2026_CVUT_reviewed.pptx
+++ b/src/site/documents/Sakala_Rozprava_2026_CVUT_reviewed.pptx
@@ -2,44 +2,44 @@
 <file path=ppt/presentation.xml><?xml version="1.0" encoding="utf-8"?>
 <p:presentation xmlns:p="http://schemas.openxmlformats.org/presentationml/2006/main" embedTrueTypeFonts="1" saveSubsetFonts="0">
   <p:sldMasterIdLst>
-    <p:sldMasterId xmlns:r="http://schemas.openxmlformats.org/officeDocument/2006/relationships" id="2147483648" r:id="R36c3e2f2a9704224"/>
+    <p:sldMasterId xmlns:r="http://schemas.openxmlformats.org/officeDocument/2006/relationships" id="2147483648" r:id="R38650ec7e2e7494f"/>
   </p:sldMasterIdLst>
   <p:notesMasterIdLst>
-    <p:notesMasterId xmlns:r="http://schemas.openxmlformats.org/officeDocument/2006/relationships" r:id="R63ff8c4e807e4281"/>
+    <p:notesMasterId xmlns:r="http://schemas.openxmlformats.org/officeDocument/2006/relationships" r:id="Raeb39f0389224796"/>
   </p:notesMasterIdLst>
   <p:sldIdLst>
-    <p:sldId xmlns:r="http://schemas.openxmlformats.org/officeDocument/2006/relationships" id="256" r:id="R371a368cb75b4cc3"/>
-    <p:sldId xmlns:r="http://schemas.openxmlformats.org/officeDocument/2006/relationships" id="257" r:id="R692384d9b6fe4af6"/>
-    <p:sldId xmlns:r="http://schemas.openxmlformats.org/officeDocument/2006/relationships" id="258" r:id="R6e24c4a4d65c450f"/>
-    <p:sldId xmlns:r="http://schemas.openxmlformats.org/officeDocument/2006/relationships" id="259" r:id="Ra7559721c88b4532"/>
-    <p:sldId xmlns:r="http://schemas.openxmlformats.org/officeDocument/2006/relationships" id="260" r:id="R18f1226a315b4898"/>
-    <p:sldId xmlns:r="http://schemas.openxmlformats.org/officeDocument/2006/relationships" id="261" r:id="R8cba09e163aa4d55"/>
-    <p:sldId xmlns:r="http://schemas.openxmlformats.org/officeDocument/2006/relationships" id="262" r:id="R3550f2753a2748ec"/>
-    <p:sldId xmlns:r="http://schemas.openxmlformats.org/officeDocument/2006/relationships" id="263" r:id="Rf498bad7d8454ad8"/>
-    <p:sldId xmlns:r="http://schemas.openxmlformats.org/officeDocument/2006/relationships" id="264" r:id="R7a76cc25dcf748dc"/>
-    <p:sldId xmlns:r="http://schemas.openxmlformats.org/officeDocument/2006/relationships" id="265" r:id="R406cbba3b2ca4800"/>
-    <p:sldId xmlns:r="http://schemas.openxmlformats.org/officeDocument/2006/relationships" id="266" r:id="R3656e9f7e8ac45f3"/>
-    <p:sldId xmlns:r="http://schemas.openxmlformats.org/officeDocument/2006/relationships" id="267" r:id="R35c3503fba2843d4"/>
-    <p:sldId xmlns:r="http://schemas.openxmlformats.org/officeDocument/2006/relationships" id="268" r:id="Ref1931ddf8574a4c"/>
-    <p:sldId xmlns:r="http://schemas.openxmlformats.org/officeDocument/2006/relationships" id="269" r:id="R1766a20a834349bc"/>
-    <p:sldId xmlns:r="http://schemas.openxmlformats.org/officeDocument/2006/relationships" id="270" r:id="R674fdcc8a0f24612"/>
-    <p:sldId xmlns:r="http://schemas.openxmlformats.org/officeDocument/2006/relationships" id="271" r:id="R8734638affee4cd4"/>
-    <p:sldId xmlns:r="http://schemas.openxmlformats.org/officeDocument/2006/relationships" id="272" r:id="R4e8071e19061460b"/>
-    <p:sldId xmlns:r="http://schemas.openxmlformats.org/officeDocument/2006/relationships" id="273" r:id="Rfabe7c600e6e4c36"/>
+    <p:sldId xmlns:r="http://schemas.openxmlformats.org/officeDocument/2006/relationships" id="256" r:id="Rdbaab46b081a4424"/>
+    <p:sldId xmlns:r="http://schemas.openxmlformats.org/officeDocument/2006/relationships" id="257" r:id="R5e235be372c34680"/>
+    <p:sldId xmlns:r="http://schemas.openxmlformats.org/officeDocument/2006/relationships" id="258" r:id="R91795c08b9114930"/>
+    <p:sldId xmlns:r="http://schemas.openxmlformats.org/officeDocument/2006/relationships" id="259" r:id="Rb8296f9546604b89"/>
+    <p:sldId xmlns:r="http://schemas.openxmlformats.org/officeDocument/2006/relationships" id="260" r:id="Rffc6990022ca4f44"/>
+    <p:sldId xmlns:r="http://schemas.openxmlformats.org/officeDocument/2006/relationships" id="261" r:id="R62cd3c20c5d64060"/>
+    <p:sldId xmlns:r="http://schemas.openxmlformats.org/officeDocument/2006/relationships" id="262" r:id="R1baa40aba83744e8"/>
+    <p:sldId xmlns:r="http://schemas.openxmlformats.org/officeDocument/2006/relationships" id="263" r:id="R3cccae2737014797"/>
+    <p:sldId xmlns:r="http://schemas.openxmlformats.org/officeDocument/2006/relationships" id="264" r:id="R6910ce6528f34738"/>
+    <p:sldId xmlns:r="http://schemas.openxmlformats.org/officeDocument/2006/relationships" id="265" r:id="Re510f6aa0e86485f"/>
+    <p:sldId xmlns:r="http://schemas.openxmlformats.org/officeDocument/2006/relationships" id="266" r:id="Rf3416c8c01ba4fda"/>
+    <p:sldId xmlns:r="http://schemas.openxmlformats.org/officeDocument/2006/relationships" id="267" r:id="R494d6ee8592a4413"/>
+    <p:sldId xmlns:r="http://schemas.openxmlformats.org/officeDocument/2006/relationships" id="268" r:id="Rd639fb3bd14a4b0d"/>
+    <p:sldId xmlns:r="http://schemas.openxmlformats.org/officeDocument/2006/relationships" id="269" r:id="Ra42f0cf0a09e440d"/>
+    <p:sldId xmlns:r="http://schemas.openxmlformats.org/officeDocument/2006/relationships" id="270" r:id="R9d578bdd46834556"/>
+    <p:sldId xmlns:r="http://schemas.openxmlformats.org/officeDocument/2006/relationships" id="271" r:id="R61233568d4394a8b"/>
+    <p:sldId xmlns:r="http://schemas.openxmlformats.org/officeDocument/2006/relationships" id="272" r:id="R5f8910ae0bd34a85"/>
+    <p:sldId xmlns:r="http://schemas.openxmlformats.org/officeDocument/2006/relationships" id="273" r:id="Ree5ab724cbe24526"/>
   </p:sldIdLst>
   <p:sldSz cx="9144000" cy="6858000"/>
   <p:notesSz cx="6858000" cy="9144000"/>
   <p:embeddedFontLst>
     <p:embeddedFont>
       <p:font typeface="Technika"/>
-      <p:regular xmlns:r="http://schemas.openxmlformats.org/officeDocument/2006/relationships" r:id="Rd359455281f34358"/>
-      <p:bold xmlns:r="http://schemas.openxmlformats.org/officeDocument/2006/relationships" r:id="R0dca4b92f8c247c1"/>
-      <p:italic xmlns:r="http://schemas.openxmlformats.org/officeDocument/2006/relationships" r:id="Re71043c9fb174917"/>
-      <p:boldItalic xmlns:r="http://schemas.openxmlformats.org/officeDocument/2006/relationships" r:id="Ra9f6fa0c6c65438c"/>
+      <p:regular xmlns:r="http://schemas.openxmlformats.org/officeDocument/2006/relationships" r:id="Rdba841fd5f5b48a8"/>
+      <p:bold xmlns:r="http://schemas.openxmlformats.org/officeDocument/2006/relationships" r:id="R819ed40ea3ae4edb"/>
+      <p:italic xmlns:r="http://schemas.openxmlformats.org/officeDocument/2006/relationships" r:id="R7c42cf049f7b4f3f"/>
+      <p:boldItalic xmlns:r="http://schemas.openxmlformats.org/officeDocument/2006/relationships" r:id="Re681bc1431cb4729"/>
     </p:embeddedFont>
     <p:embeddedFont>
       <p:font typeface="Technika-Bold"/>
-      <p:regular xmlns:r="http://schemas.openxmlformats.org/officeDocument/2006/relationships" r:id="R3e830c9c37ef4ac8"/>
+      <p:regular xmlns:r="http://schemas.openxmlformats.org/officeDocument/2006/relationships" r:id="Re2a2eba4fd7c4667"/>
     </p:embeddedFont>
   </p:embeddedFontLst>
 </p:presentation>
@@ -418,7 +418,7 @@
           <a:lstStyle xmlns:a="http://schemas.openxmlformats.org/drawingml/2006/main"/>
           <a:p xmlns:a="http://schemas.openxmlformats.org/drawingml/2006/main">
             <a:r>
-              <a:t>Návrh rozsahu pro odbornou rozpravu po prvních dvou letech. Povinný Tier 1 zahrnuje atmosférický vzduch, predikci a TCO. Širší aplikační kontext je přechod od SF₆. Tier 1 zkoumá laserem vyvolané sepnutí atmosférické mezery. Netestuje náhradu izolace ani funkci výkonového vypínače. Odevzdání srpen 2028. Tier 2 a 3 jsou mimo povinné dokončení. Šablona: ČVUT, https://www.cvut.cz/logo-a-graficky-manual, soubor PowerPoint_CS.potx. Hlavní část přibližně 15 až 20 minut. Přesný čas podle pozvánky.</a:t>
+              <a:t>Návrh rozsahu pro odbornou rozpravu po prvních dvou letech. Povinný Tier 1 zahrnuje atmosférický vzduch, predikci a TCO. Odevzdání srpen 2028. Tier 2 a 3 jsou mimo povinné dokončení. Šablona: ČVUT, https://www.cvut.cz/logo-a-graficky-manual, soubor PowerPoint_CS.potx. Hlavní část přibližně 15–20 minut; přesný čas podle pozvánky.</a:t>
             </a:r>
           </a:p>
           <a:p xmlns:a="http://schemas.openxmlformats.org/drawingml/2006/main">
@@ -1128,12 +1128,7 @@
           <a:lstStyle xmlns:a="http://schemas.openxmlformats.org/drawingml/2006/main"/>
           <a:p xmlns:a="http://schemas.openxmlformats.org/drawingml/2006/main">
             <a:r>
-              <a:t>Přechod od SF₆ je reálný regulační a průmyslový kontext. SF₆ však v rozváděčích zajišťuje elektrickou izolaci a zhášení oblouku. Současný Tier 1 studuje pouze laserem vyvolané sepnutí atmosférické mezery. Neprokazuje izolační koordinaci, přerušení zkratového proudu, post-arc dielektrické zotavení ani produktovou životnost. Přímou vazbu na náhradu SF₆ lze tvrdit až po validaci konkrétní spínací funkce, média, napěťového a proudového dimenzování a pracovního cyklu. Tier 2 může ověřit přenos metody do CO₂ a tlakového režimu. Tier 3 může řešit vybranou aplikaci. Ani jeden není podmínkou odevzdání v srpnu 2028.</a:t>
-            </a:r>
-          </a:p>
-          <a:p xmlns:a="http://schemas.openxmlformats.org/drawingml/2006/main">
-            <a:r>
-              <a:t>Sources: Regulation (EU) 2024/573, Article 13, https://eur-lex.europa.eu/eli/reg/2024/573/oj. CIGRE WG A3.41, Current interruption in SF₆-free switchgear, Technical Brochure 871, 2022, https://electra.cigre.org/322-june-2022/technical-brochures/871-current-interruption-in-sf6-free-switchgear.html.</a:t>
+              <a:t>Dlouhodobým cílem programu W je přispět k náhradě SF₆ technicky a ekonomicky životaschopnými vysokonapěťovými zařízeními. Tier 1 vytváří měřicí, predikční a ekonomický základ. Tier 2 může ověřit přenos do CO₂ a tlakových podmínek, Tier 3 navázat aplikacemi. Prokázání úplné náhrady SF₆ není podmínkou odevzdání disertace. W znamená celý výzkumný program. Disertace je vymezena Tier 1; CO₂ není podmínkou názvu ani výsledků disertace. Jde o uživatelem zvolený plán, nikoli o tvrzení, že jej již schválila komise.</a:t>
             </a:r>
           </a:p>
         </p:txBody>
@@ -1679,7 +1674,7 @@
           <p:nvPr/>
         </p:nvPicPr>
         <p:blipFill rotWithShape="1">
-          <a:blip xmlns:r="http://schemas.openxmlformats.org/officeDocument/2006/relationships" xmlns:a="http://schemas.openxmlformats.org/drawingml/2006/main" r:embed="R816c3bc791634ab1"/>
+          <a:blip xmlns:r="http://schemas.openxmlformats.org/officeDocument/2006/relationships" xmlns:a="http://schemas.openxmlformats.org/drawingml/2006/main" r:embed="R733499d344b14d39"/>
           <a:srcRect xmlns:a="http://schemas.openxmlformats.org/drawingml/2006/main" l="0" t="-1" r="0" b="-1"/>
           <a:stretch xmlns:a="http://schemas.openxmlformats.org/drawingml/2006/main"/>
         </p:blipFill>
@@ -1845,7 +1840,7 @@
           <p:nvPr/>
         </p:nvPicPr>
         <p:blipFill>
-          <a:blip xmlns:r="http://schemas.openxmlformats.org/officeDocument/2006/relationships" xmlns:a="http://schemas.openxmlformats.org/drawingml/2006/main" r:embed="R136f982813054371"/>
+          <a:blip xmlns:r="http://schemas.openxmlformats.org/officeDocument/2006/relationships" xmlns:a="http://schemas.openxmlformats.org/drawingml/2006/main" r:embed="R4afd8b7c142741b0"/>
           <a:stretch xmlns:a="http://schemas.openxmlformats.org/drawingml/2006/main">
             <a:fillRect l="0" t="0" r="0" b="0"/>
           </a:stretch>
@@ -1886,7 +1881,7 @@
           <p:nvPr/>
         </p:nvPicPr>
         <p:blipFill rotWithShape="1">
-          <a:blip xmlns:r="http://schemas.openxmlformats.org/officeDocument/2006/relationships" xmlns:a="http://schemas.openxmlformats.org/drawingml/2006/main" r:embed="R9f99823fc5394627"/>
+          <a:blip xmlns:r="http://schemas.openxmlformats.org/officeDocument/2006/relationships" xmlns:a="http://schemas.openxmlformats.org/drawingml/2006/main" r:embed="R4d9219a7cecf4e55"/>
           <a:srcRect xmlns:a="http://schemas.openxmlformats.org/drawingml/2006/main" l="0" t="0" r="0" b="0"/>
           <a:stretch xmlns:a="http://schemas.openxmlformats.org/drawingml/2006/main"/>
         </p:blipFill>
@@ -1909,7 +1904,7 @@
           <p:nvPr/>
         </p:nvPicPr>
         <p:blipFill>
-          <a:blip xmlns:r="http://schemas.openxmlformats.org/officeDocument/2006/relationships" xmlns:a="http://schemas.openxmlformats.org/drawingml/2006/main" r:embed="R18a1d0b3230e43f0"/>
+          <a:blip xmlns:r="http://schemas.openxmlformats.org/officeDocument/2006/relationships" xmlns:a="http://schemas.openxmlformats.org/drawingml/2006/main" r:embed="R6656fdf206f147bd"/>
           <a:srcRect xmlns:a="http://schemas.openxmlformats.org/drawingml/2006/main" l="0" t="0" r="0" b="0"/>
           <a:stretch xmlns:a="http://schemas.openxmlformats.org/drawingml/2006/main">
             <a:fillRect l="0" t="0" r="0" b="0"/>
@@ -2495,7 +2490,7 @@
           <p:nvPr/>
         </p:nvPicPr>
         <p:blipFill>
-          <a:blip xmlns:r="http://schemas.openxmlformats.org/officeDocument/2006/relationships" xmlns:a="http://schemas.openxmlformats.org/drawingml/2006/main" r:embed="Rfed35eb2338e4d42"/>
+          <a:blip xmlns:r="http://schemas.openxmlformats.org/officeDocument/2006/relationships" xmlns:a="http://schemas.openxmlformats.org/drawingml/2006/main" r:embed="R3ebba90d1e764519"/>
           <a:srcRect xmlns:a="http://schemas.openxmlformats.org/drawingml/2006/main" l="0" t="0" r="0" b="0"/>
           <a:stretch xmlns:a="http://schemas.openxmlformats.org/drawingml/2006/main">
             <a:fillRect l="0" t="0" r="0" b="0"/>
@@ -2515,11 +2510,11 @@
   </p:cSld>
   <p:clrMap bg1="lt1" tx1="dk1" bg2="lt2" tx2="dk2" accent1="accent1" accent2="accent2" accent3="accent3" accent4="accent4" accent5="accent5" accent6="accent6" hlink="hlink" folHlink="folHlink"/>
   <p:sldLayoutIdLst>
-    <p:sldLayoutId xmlns:r="http://schemas.openxmlformats.org/officeDocument/2006/relationships" id="2147483649" r:id="Rfe523ed7b7674ef3"/>
-    <p:sldLayoutId xmlns:r="http://schemas.openxmlformats.org/officeDocument/2006/relationships" id="2147483650" r:id="Rda450103731f4caa"/>
-    <p:sldLayoutId xmlns:r="http://schemas.openxmlformats.org/officeDocument/2006/relationships" id="2147483651" r:id="Ra5b529903a824e24"/>
-    <p:sldLayoutId xmlns:r="http://schemas.openxmlformats.org/officeDocument/2006/relationships" id="2147483652" r:id="R524557f218304ac6"/>
-    <p:sldLayoutId xmlns:r="http://schemas.openxmlformats.org/officeDocument/2006/relationships" id="2147483653" r:id="R3e6ee01eefeb466d"/>
+    <p:sldLayoutId xmlns:r="http://schemas.openxmlformats.org/officeDocument/2006/relationships" id="2147483649" r:id="R7c9422a675be4ff1"/>
+    <p:sldLayoutId xmlns:r="http://schemas.openxmlformats.org/officeDocument/2006/relationships" id="2147483650" r:id="Ra0b62cbc17d44767"/>
+    <p:sldLayoutId xmlns:r="http://schemas.openxmlformats.org/officeDocument/2006/relationships" id="2147483651" r:id="R9bbf3acf1b8e4baa"/>
+    <p:sldLayoutId xmlns:r="http://schemas.openxmlformats.org/officeDocument/2006/relationships" id="2147483652" r:id="Ra95fc6c1f82246e4"/>
+    <p:sldLayoutId xmlns:r="http://schemas.openxmlformats.org/officeDocument/2006/relationships" id="2147483653" r:id="R882fad74db3b429d"/>
   </p:sldLayoutIdLst>
   <p:txStyles>
     <p:titleStyle>
@@ -3254,7 +3249,7 @@
                 <a:ea typeface="Technika"/>
                 <a:cs typeface="Technika"/>
               </a:rPr>
-              <a:t>Výzkum řízeného sepnutí vzduchové mezery v kontextu technologií bez SF₆.</a:t>
+              <a:t>Atmosférický základ pro dlouhodobý cíl: technicky a ekonomicky</a:t>
             </a:r>
           </a:p>
           <a:p xmlns:a="http://schemas.openxmlformats.org/drawingml/2006/main">
@@ -3278,7 +3273,7 @@
                 <a:ea typeface="Technika"/>
                 <a:cs typeface="Technika"/>
               </a:rPr>
-              <a:t>Tier 1 neprokazuje náhradu celého rozváděče.</a:t>
+              <a:t>životaschopná vysokonapěťová zařízení bez SF₆.</a:t>
             </a:r>
           </a:p>
         </p:txBody>
@@ -7162,7 +7157,7 @@
                 <a:ea typeface="Technika-Bold"/>
                 <a:cs typeface="Technika-Bold"/>
               </a:rPr>
-              <a:t>Aplikační kontext a rozsah disertace</a:t>
+              <a:t>Dlouhodobý cíl a rozsah disertace</a:t>
             </a:r>
             <a:endParaRPr/>
           </a:p>
@@ -7268,7 +7263,7 @@
                 <a:ea typeface="Technika"/>
                 <a:cs typeface="Technika"/>
               </a:rPr>
-              <a:t>Kontext: přechod k technologiím bez SF₆ a F-plynů.</a:t>
+              <a:t>Cíl programu: přispět k náhradě SF₆ ve vysokonapěťových zařízeních.</a:t>
             </a:r>
           </a:p>
         </p:txBody>
@@ -7326,7 +7321,7 @@
                 <a:ea typeface="Technika"/>
                 <a:cs typeface="Technika"/>
               </a:rPr>
-              <a:t>Tier 1: řízené sepnutí vzduchové mezery, predikce a TCO.</a:t>
+              <a:t>Tier 1: atmosférický vzduch, predikce a TCO.</a:t>
             </a:r>
           </a:p>
         </p:txBody>
@@ -7384,7 +7379,7 @@
                 <a:ea typeface="Technika"/>
                 <a:cs typeface="Technika"/>
               </a:rPr>
-              <a:t>Tier 1 netestuje izolaci, přerušení proudu ani dielektrické zotavení.</a:t>
+              <a:t>Odevzdání disertace: srpen 2028.</a:t>
             </a:r>
           </a:p>
         </p:txBody>
@@ -7442,7 +7437,7 @@
                 <a:ea typeface="Technika"/>
                 <a:cs typeface="Technika"/>
               </a:rPr>
-              <a:t>Odevzdání 08/2028. Tier 2 a 3 jako samostatné pokračování.</a:t>
+              <a:t>Tier 2 a 3: navazující výzkum mimo povinné dokončení.</a:t>
             </a:r>
           </a:p>
         </p:txBody>
@@ -8155,7 +8150,7 @@
           <p:nvPr/>
         </p:nvPicPr>
         <p:blipFill>
-          <a:blip xmlns:r="http://schemas.openxmlformats.org/officeDocument/2006/relationships" xmlns:a="http://schemas.openxmlformats.org/drawingml/2006/main" r:embed="Rb17dde5652c74691"/>
+          <a:blip xmlns:r="http://schemas.openxmlformats.org/officeDocument/2006/relationships" xmlns:a="http://schemas.openxmlformats.org/drawingml/2006/main" r:embed="Rf798fc67d91f4fb4"/>
           <a:stretch xmlns:a="http://schemas.openxmlformats.org/drawingml/2006/main"/>
         </p:blipFill>
         <p:spPr>
@@ -10841,13 +10836,13 @@
 </file>
 
 <file path=customXml/itemProps1.xml><?xml version="1.0" encoding="utf-8"?>
-<ds:datastoreItem xmlns:ds="http://schemas.openxmlformats.org/officeDocument/2006/customXml" ds:itemID="{5F217968-9E1A-44D1-8665-3311905331B5}"/>
+<ds:datastoreItem xmlns:ds="http://schemas.openxmlformats.org/officeDocument/2006/customXml" ds:itemID="{E61DFFA2-A8B0-4D2F-86B6-456B50AD5D10}"/>
 </file>
 
 <file path=customXml/itemProps2.xml><?xml version="1.0" encoding="utf-8"?>
-<ds:datastoreItem xmlns:ds="http://schemas.openxmlformats.org/officeDocument/2006/customXml" ds:itemID="{A84A42CC-8DB2-45C2-B271-524D7F98198C}"/>
+<ds:datastoreItem xmlns:ds="http://schemas.openxmlformats.org/officeDocument/2006/customXml" ds:itemID="{E9552D97-AF06-43CF-9CCC-789489FD50EB}"/>
 </file>
 
 <file path=customXml/itemProps3.xml><?xml version="1.0" encoding="utf-8"?>
-<ds:datastoreItem xmlns:ds="http://schemas.openxmlformats.org/officeDocument/2006/customXml" ds:itemID="{200AAFDB-2075-4D73-99CD-267B2BC156B0}"/>
+<ds:datastoreItem xmlns:ds="http://schemas.openxmlformats.org/officeDocument/2006/customXml" ds:itemID="{024889D1-DFE9-4C85-98AB-841F25DB04E9}"/>
 </file>
</xml_diff>